<commit_message>
Update presentation.pptx with final adjustments and enhancements
</commit_message>
<xml_diff>
--- a/results/presentation.pptx
+++ b/results/presentation.pptx
@@ -3704,7 +3704,7 @@
                   <a:srgbClr val="555555"/>
                 </a:solidFill>
               </a:rPr>
-              <a:t>CBS runtime grows with agents but remains tractable at low counts | baseline shown for reference</a:t>
+              <a:t>CBS runtime grows with agents but remains tractable | Joint A* baseline fails completely (0% success) from 8 agents onward</a:t>
             </a:r>
           </a:p>
         </p:txBody>
@@ -5122,7 +5122,7 @@
                   <a:srgbClr val="2C2C2C"/>
                 </a:solidFill>
               </a:rPr>
-              <a:t>• Finds optimal, conflict-free solutions — scales far better than joint A*</a:t>
+              <a:t>• Finds optimal, conflict-free solutions — Joint A* fails completely (0%) from 8 agents onward</a:t>
             </a:r>
           </a:p>
         </p:txBody>
@@ -5983,7 +5983,7 @@
                   <a:srgbClr val="2C2C2C"/>
                 </a:solidFill>
               </a:rPr>
-              <a:t>• Extension: warehouse maps create 2–3× more CT expansions than open maps</a:t>
+              <a:t>• Extension: warehouse maps create 3.7× more CT expansions than open maps (20 agents)</a:t>
             </a:r>
           </a:p>
         </p:txBody>
@@ -10457,7 +10457,7 @@
                   <a:srgbClr val="2C2C2C"/>
                 </a:solidFill>
               </a:rPr>
-              <a:t>• benchmark.py — Map generation, instance runner  [Kfir]</a:t>
+              <a:t>• benchmark.py / joint_astar.py — Joint-State-Space A* baseline, instance runner  [Kfir]</a:t>
             </a:r>
           </a:p>
         </p:txBody>
@@ -10968,7 +10968,7 @@
                   <a:srgbClr val="555555"/>
                 </a:solidFill>
               </a:rPr>
-              <a:t>CBS success rate drops as agents increase | 25 instances per count | 20×20 open grid | 30s time limit</a:t>
+              <a:t>CBS vs. Joint-State-Space A* baseline | 25 instances per count | 20×20 open grid | CBS: 30s limit, Joint A*: 5s limit</a:t>
             </a:r>
           </a:p>
         </p:txBody>

</xml_diff>